<commit_message>
Add Lancet-PH additional analyses: warming projection, time-of-day mechanism, road-user/age vulnerability
Co-Authored-By: Tatsuki Onishi <bougtoir@gmail.com>
</commit_message>
<xml_diff>
--- a/heat_accidents_mortality/output/manuscript/figures.pptx
+++ b/heat_accidents_mortality/output/manuscript/figures.pptx
@@ -12,6 +12,9 @@
     <p:sldId id="260" r:id="rId11"/>
     <p:sldId id="261" r:id="rId12"/>
     <p:sldId id="262" r:id="rId13"/>
+    <p:sldId id="263" r:id="rId14"/>
+    <p:sldId id="264" r:id="rId15"/>
+    <p:sldId id="265" r:id="rId16"/>
   </p:sldIdLst>
   <p:sldSz cx="12191695" cy="6858000" type="screen4x3"/>
   <p:notesSz cx="6858000" cy="9144000"/>
@@ -3184,6 +3187,106 @@
 </p:sld>
 </file>
 
+<file path=ppt/slides/slide10.xml><?xml version="1.0" encoding="utf-8"?>
+<p:sld xmlns:a="http://schemas.openxmlformats.org/drawingml/2006/main" xmlns:p="http://schemas.openxmlformats.org/presentationml/2006/main" xmlns:r="http://schemas.openxmlformats.org/officeDocument/2006/relationships">
+  <p:cSld>
+    <p:spTree>
+      <p:nvGrpSpPr>
+        <p:cNvPr id="1" name=""/>
+        <p:cNvGrpSpPr/>
+        <p:nvPr/>
+      </p:nvGrpSpPr>
+      <p:grpSpPr/>
+      <p:sp>
+        <p:nvSpPr>
+          <p:cNvPr id="2" name="TextBox 1"/>
+          <p:cNvSpPr txBox="1"/>
+          <p:nvPr/>
+        </p:nvSpPr>
+        <p:spPr>
+          <a:xfrm>
+            <a:off x="457200" y="182880"/>
+            <a:ext cx="11247120" cy="548640"/>
+          </a:xfrm>
+          <a:prstGeom prst="rect">
+            <a:avLst/>
+          </a:prstGeom>
+          <a:noFill/>
+        </p:spPr>
+        <p:txBody>
+          <a:bodyPr wrap="none">
+            <a:spAutoFit/>
+          </a:bodyPr>
+          <a:lstStyle/>
+          <a:p>
+            <a:r>
+              <a:rPr sz="2200" b="1"/>
+              <a:t>Figure 10</a:t>
+            </a:r>
+          </a:p>
+        </p:txBody>
+      </p:sp>
+      <p:pic>
+        <p:nvPicPr>
+          <p:cNvPr id="3" name="Picture 2" descr="cross_fig_us_vs_japan_sameday.png"/>
+          <p:cNvPicPr>
+            <a:picLocks noChangeAspect="1"/>
+          </p:cNvPicPr>
+          <p:nvPr/>
+        </p:nvPicPr>
+        <p:blipFill>
+          <a:blip r:embed="rId2"/>
+          <a:stretch>
+            <a:fillRect/>
+          </a:stretch>
+        </p:blipFill>
+        <p:spPr>
+          <a:xfrm>
+            <a:off x="2286000" y="914400"/>
+            <a:ext cx="5974318" cy="4389120"/>
+          </a:xfrm>
+          <a:prstGeom prst="rect">
+            <a:avLst/>
+          </a:prstGeom>
+        </p:spPr>
+      </p:pic>
+      <p:sp>
+        <p:nvSpPr>
+          <p:cNvPr id="4" name="TextBox 3"/>
+          <p:cNvSpPr txBox="1"/>
+          <p:nvPr/>
+        </p:nvSpPr>
+        <p:spPr>
+          <a:xfrm>
+            <a:off x="457200" y="5486400"/>
+            <a:ext cx="11247120" cy="1188720"/>
+          </a:xfrm>
+          <a:prstGeom prst="rect">
+            <a:avLst/>
+          </a:prstGeom>
+          <a:noFill/>
+        </p:spPr>
+        <p:txBody>
+          <a:bodyPr wrap="square">
+            <a:spAutoFit/>
+          </a:bodyPr>
+          <a:lstStyle/>
+          <a:p>
+            <a:r>
+              <a:rPr sz="1200"/>
+              <a:t>Same-day rate ratio of traffic-crash deaths for a +9 C anomaly, United States versus Japan. The US shows a precise acute effect; the Japanese estimate is underpowered.</a:t>
+            </a:r>
+          </a:p>
+        </p:txBody>
+      </p:sp>
+    </p:spTree>
+  </p:cSld>
+  <p:clrMapOvr>
+    <a:masterClrMapping/>
+  </p:clrMapOvr>
+</p:sld>
+</file>
+
 <file path=ppt/slides/slide2.xml><?xml version="1.0" encoding="utf-8"?>
 <p:sld xmlns:a="http://schemas.openxmlformats.org/drawingml/2006/main" xmlns:p="http://schemas.openxmlformats.org/presentationml/2006/main" xmlns:r="http://schemas.openxmlformats.org/officeDocument/2006/relationships">
   <p:cSld>
@@ -3425,7 +3528,7 @@
       </p:sp>
       <p:pic>
         <p:nvPicPr>
-          <p:cNvPr id="3" name="Picture 2" descr="fig4_attributable_by_year.png"/>
+          <p:cNvPr id="3" name="Picture 2" descr="fig_us_roaduser.png"/>
           <p:cNvPicPr>
             <a:picLocks noChangeAspect="1"/>
           </p:cNvPicPr>
@@ -3440,7 +3543,7 @@
         <p:spPr>
           <a:xfrm>
             <a:off x="2286000" y="914400"/>
-            <a:ext cx="5735875" cy="4389120"/>
+            <a:ext cx="6749997" cy="4389120"/>
           </a:xfrm>
           <a:prstGeom prst="rect">
             <a:avLst/>
@@ -3471,7 +3574,7 @@
           <a:p>
             <a:r>
               <a:rPr sz="1200"/>
-              <a:t>United States estimated net heat-attributable crash deaths per year, 2016-2022.</a:t>
+              <a:t>United States same-day rate ratio of crash death for a +9 C anomaly by road-user type. Open-air users (motorcyclists, pedestrians, cyclists) show much larger heat effects than enclosed, often air-conditioned, vehicle occupants -- a gradient that tracks direct heat exposure rather than driving volume.</a:t>
             </a:r>
           </a:p>
         </p:txBody>
@@ -3525,7 +3628,7 @@
       </p:sp>
       <p:pic>
         <p:nvPicPr>
-          <p:cNvPr id="3" name="Picture 2" descr="fig5_hidden_vs_official.png"/>
+          <p:cNvPr id="3" name="Picture 2" descr="fig_us_timeofday.png"/>
           <p:cNvPicPr>
             <a:picLocks noChangeAspect="1"/>
           </p:cNvPicPr>
@@ -3540,7 +3643,7 @@
         <p:spPr>
           <a:xfrm>
             <a:off x="2286000" y="914400"/>
-            <a:ext cx="5778600" cy="4389120"/>
+            <a:ext cx="5800779" cy="4389120"/>
           </a:xfrm>
           <a:prstGeom prst="rect">
             <a:avLst/>
@@ -3571,7 +3674,7 @@
           <a:p>
             <a:r>
               <a:rPr sz="1200"/>
-              <a:t>United States comparison of estimated net heat-attributable crash deaths per year with officially recorded direct-heat deaths (ICD-10 X30) from CDC WONDER.</a:t>
+              <a:t>United States same-day rate ratio of crash death for a +9 C anomaly by crash hour of day. The excess is largest for crashes in the hottest part of the day (12-17 h) and weakest in the cool morning (06-11 h).</a:t>
             </a:r>
           </a:p>
         </p:txBody>
@@ -3625,7 +3728,7 @@
       </p:sp>
       <p:pic>
         <p:nvPicPr>
-          <p:cNvPr id="3" name="Picture 2" descr="jp_fig2_anomaly_exposure_response.png"/>
+          <p:cNvPr id="3" name="Picture 2" descr="fig4_attributable_by_year.png"/>
           <p:cNvPicPr>
             <a:picLocks noChangeAspect="1"/>
           </p:cNvPicPr>
@@ -3640,7 +3743,7 @@
         <p:spPr>
           <a:xfrm>
             <a:off x="2286000" y="914400"/>
-            <a:ext cx="6139646" cy="4389120"/>
+            <a:ext cx="5735875" cy="4389120"/>
           </a:xfrm>
           <a:prstGeom prst="rect">
             <a:avLst/>
@@ -3671,7 +3774,7 @@
           <a:p>
             <a:r>
               <a:rPr sz="1200"/>
-              <a:t>Japan temperature-anomaly exposure-response (2019-2024). The estimate is imprecise: the confidence band is wide and includes the null throughout.</a:t>
+              <a:t>United States estimated net heat-attributable crash deaths per year, 2016-2022.</a:t>
             </a:r>
           </a:p>
         </p:txBody>
@@ -3725,7 +3828,7 @@
       </p:sp>
       <p:pic>
         <p:nvPicPr>
-          <p:cNvPr id="3" name="Picture 2" descr="cross_fig_us_vs_japan_sameday.png"/>
+          <p:cNvPr id="3" name="Picture 2" descr="fig5_hidden_vs_official.png"/>
           <p:cNvPicPr>
             <a:picLocks noChangeAspect="1"/>
           </p:cNvPicPr>
@@ -3740,7 +3843,7 @@
         <p:spPr>
           <a:xfrm>
             <a:off x="2286000" y="914400"/>
-            <a:ext cx="5974318" cy="4389120"/>
+            <a:ext cx="5778600" cy="4389120"/>
           </a:xfrm>
           <a:prstGeom prst="rect">
             <a:avLst/>
@@ -3771,7 +3874,207 @@
           <a:p>
             <a:r>
               <a:rPr sz="1200"/>
-              <a:t>Same-day rate ratio of traffic-crash deaths for a +9 C anomaly, United States versus Japan. The US shows a precise acute effect; the Japanese estimate is underpowered.</a:t>
+              <a:t>United States comparison of estimated net heat-attributable crash deaths per year with officially recorded direct-heat deaths (ICD-10 X30) from CDC WONDER.</a:t>
+            </a:r>
+          </a:p>
+        </p:txBody>
+      </p:sp>
+    </p:spTree>
+  </p:cSld>
+  <p:clrMapOvr>
+    <a:masterClrMapping/>
+  </p:clrMapOvr>
+</p:sld>
+</file>
+
+<file path=ppt/slides/slide8.xml><?xml version="1.0" encoding="utf-8"?>
+<p:sld xmlns:a="http://schemas.openxmlformats.org/drawingml/2006/main" xmlns:p="http://schemas.openxmlformats.org/presentationml/2006/main" xmlns:r="http://schemas.openxmlformats.org/officeDocument/2006/relationships">
+  <p:cSld>
+    <p:spTree>
+      <p:nvGrpSpPr>
+        <p:cNvPr id="1" name=""/>
+        <p:cNvGrpSpPr/>
+        <p:nvPr/>
+      </p:nvGrpSpPr>
+      <p:grpSpPr/>
+      <p:sp>
+        <p:nvSpPr>
+          <p:cNvPr id="2" name="TextBox 1"/>
+          <p:cNvSpPr txBox="1"/>
+          <p:nvPr/>
+        </p:nvSpPr>
+        <p:spPr>
+          <a:xfrm>
+            <a:off x="457200" y="182880"/>
+            <a:ext cx="11247120" cy="548640"/>
+          </a:xfrm>
+          <a:prstGeom prst="rect">
+            <a:avLst/>
+          </a:prstGeom>
+          <a:noFill/>
+        </p:spPr>
+        <p:txBody>
+          <a:bodyPr wrap="none">
+            <a:spAutoFit/>
+          </a:bodyPr>
+          <a:lstStyle/>
+          <a:p>
+            <a:r>
+              <a:rPr sz="2200" b="1"/>
+              <a:t>Figure 8</a:t>
+            </a:r>
+          </a:p>
+        </p:txBody>
+      </p:sp>
+      <p:pic>
+        <p:nvPicPr>
+          <p:cNvPr id="3" name="Picture 2" descr="fig_us_projection.png"/>
+          <p:cNvPicPr>
+            <a:picLocks noChangeAspect="1"/>
+          </p:cNvPicPr>
+          <p:nvPr/>
+        </p:nvPicPr>
+        <p:blipFill>
+          <a:blip r:embed="rId2"/>
+          <a:stretch>
+            <a:fillRect/>
+          </a:stretch>
+        </p:blipFill>
+        <p:spPr>
+          <a:xfrm>
+            <a:off x="2286000" y="914400"/>
+            <a:ext cx="5833230" cy="4389120"/>
+          </a:xfrm>
+          <a:prstGeom prst="rect">
+            <a:avLst/>
+          </a:prstGeom>
+        </p:spPr>
+      </p:pic>
+      <p:sp>
+        <p:nvSpPr>
+          <p:cNvPr id="4" name="TextBox 3"/>
+          <p:cNvSpPr txBox="1"/>
+          <p:nvPr/>
+        </p:nvSpPr>
+        <p:spPr>
+          <a:xfrm>
+            <a:off x="457200" y="5486400"/>
+            <a:ext cx="11247120" cy="1188720"/>
+          </a:xfrm>
+          <a:prstGeom prst="rect">
+            <a:avLst/>
+          </a:prstGeom>
+          <a:noFill/>
+        </p:spPr>
+        <p:txBody>
+          <a:bodyPr wrap="square">
+            <a:spAutoFit/>
+          </a:bodyPr>
+          <a:lstStyle/>
+          <a:p>
+            <a:r>
+              <a:rPr sz="1200"/>
+              <a:t>United States projected additional traffic-crash deaths per year under uniform warming of the daily temperature distribution by +1, +2 and +3 C, holding driving activity and baseline rates constant. Bars show the point estimate with 95% Monte Carlo confidence intervals; this is a scenario projection, not an observed quantity.</a:t>
+            </a:r>
+          </a:p>
+        </p:txBody>
+      </p:sp>
+    </p:spTree>
+  </p:cSld>
+  <p:clrMapOvr>
+    <a:masterClrMapping/>
+  </p:clrMapOvr>
+</p:sld>
+</file>
+
+<file path=ppt/slides/slide9.xml><?xml version="1.0" encoding="utf-8"?>
+<p:sld xmlns:a="http://schemas.openxmlformats.org/drawingml/2006/main" xmlns:p="http://schemas.openxmlformats.org/presentationml/2006/main" xmlns:r="http://schemas.openxmlformats.org/officeDocument/2006/relationships">
+  <p:cSld>
+    <p:spTree>
+      <p:nvGrpSpPr>
+        <p:cNvPr id="1" name=""/>
+        <p:cNvGrpSpPr/>
+        <p:nvPr/>
+      </p:nvGrpSpPr>
+      <p:grpSpPr/>
+      <p:sp>
+        <p:nvSpPr>
+          <p:cNvPr id="2" name="TextBox 1"/>
+          <p:cNvSpPr txBox="1"/>
+          <p:nvPr/>
+        </p:nvSpPr>
+        <p:spPr>
+          <a:xfrm>
+            <a:off x="457200" y="182880"/>
+            <a:ext cx="11247120" cy="548640"/>
+          </a:xfrm>
+          <a:prstGeom prst="rect">
+            <a:avLst/>
+          </a:prstGeom>
+          <a:noFill/>
+        </p:spPr>
+        <p:txBody>
+          <a:bodyPr wrap="none">
+            <a:spAutoFit/>
+          </a:bodyPr>
+          <a:lstStyle/>
+          <a:p>
+            <a:r>
+              <a:rPr sz="2200" b="1"/>
+              <a:t>Figure 9</a:t>
+            </a:r>
+          </a:p>
+        </p:txBody>
+      </p:sp>
+      <p:pic>
+        <p:nvPicPr>
+          <p:cNvPr id="3" name="Picture 2" descr="jp_fig2_anomaly_exposure_response.png"/>
+          <p:cNvPicPr>
+            <a:picLocks noChangeAspect="1"/>
+          </p:cNvPicPr>
+          <p:nvPr/>
+        </p:nvPicPr>
+        <p:blipFill>
+          <a:blip r:embed="rId2"/>
+          <a:stretch>
+            <a:fillRect/>
+          </a:stretch>
+        </p:blipFill>
+        <p:spPr>
+          <a:xfrm>
+            <a:off x="2286000" y="914400"/>
+            <a:ext cx="6139646" cy="4389120"/>
+          </a:xfrm>
+          <a:prstGeom prst="rect">
+            <a:avLst/>
+          </a:prstGeom>
+        </p:spPr>
+      </p:pic>
+      <p:sp>
+        <p:nvSpPr>
+          <p:cNvPr id="4" name="TextBox 3"/>
+          <p:cNvSpPr txBox="1"/>
+          <p:nvPr/>
+        </p:nvSpPr>
+        <p:spPr>
+          <a:xfrm>
+            <a:off x="457200" y="5486400"/>
+            <a:ext cx="11247120" cy="1188720"/>
+          </a:xfrm>
+          <a:prstGeom prst="rect">
+            <a:avLst/>
+          </a:prstGeom>
+          <a:noFill/>
+        </p:spPr>
+        <p:txBody>
+          <a:bodyPr wrap="square">
+            <a:spAutoFit/>
+          </a:bodyPr>
+          <a:lstStyle/>
+          <a:p>
+            <a:r>
+              <a:rPr sz="1200"/>
+              <a:t>Japan temperature-anomaly exposure-response (2019-2024). The estimate is imprecise: the confidence band is wide and includes the null throughout.</a:t>
             </a:r>
           </a:p>
         </p:txBody>

</xml_diff>

<commit_message>
AAP submission: reviewer-level revision of wording, accuracy and consistency
Co-Authored-By: Tatsuki Onishi <bougtoir@gmail.com>
</commit_message>
<xml_diff>
--- a/heat_accidents_mortality/output/manuscript/figures.pptx
+++ b/heat_accidents_mortality/output/manuscript/figures.pptx
@@ -3274,7 +3274,7 @@
           <a:p>
             <a:r>
               <a:rPr sz="1200"/>
-              <a:t>Same-day rate ratio of traffic-crash deaths for a +9 C anomaly, United States versus Japan. The US shows a precise acute effect; the Japanese estimate is underpowered.</a:t>
+              <a:t>Same-day rate ratio of traffic-crash deaths for a +9 °C anomaly, United States versus Japan. The US shows a precise acute effect; the Japanese estimate is underpowered.</a:t>
             </a:r>
           </a:p>
         </p:txBody>
@@ -3474,7 +3474,7 @@
           <a:p>
             <a:r>
               <a:rPr sz="1200"/>
-              <a:t>United States lag structure of the crash-death response to a +9 C anomaly: an acute same-day excess followed by a 1-3 day deficit consistent with short-term mortality displacement.</a:t>
+              <a:t>United States lag structure of the crash-death response to a +9 °C anomaly: an acute same-day excess followed by a 1-3 day deficit consistent with short-term mortality displacement.</a:t>
             </a:r>
           </a:p>
         </p:txBody>
@@ -3574,7 +3574,7 @@
           <a:p>
             <a:r>
               <a:rPr sz="1200"/>
-              <a:t>United States same-day rate ratio of crash death for a +9 C anomaly by road-user type. Open-air users (motorcyclists, pedestrians, cyclists) show much larger heat effects than enclosed, often air-conditioned, vehicle occupants—a gradient that tracks direct heat exposure rather than driving volume.</a:t>
+              <a:t>United States same-day rate ratio of crash death for a +9 °C anomaly by road-user type. Open-air users (motorcyclists, pedestrians, cyclists) show much larger heat effects than enclosed, often air-conditioned, vehicle occupants—a gradient that tracks direct heat exposure rather than driving volume.</a:t>
             </a:r>
           </a:p>
         </p:txBody>
@@ -3674,7 +3674,7 @@
           <a:p>
             <a:r>
               <a:rPr sz="1200"/>
-              <a:t>United States same-day rate ratio of crash death for a +9 C anomaly by crash hour of day. The excess is largest for crashes in the hottest part of the day (12-17 h) and weakest in the cool morning (06-11 h).</a:t>
+              <a:t>United States same-day rate ratio of crash death for a +9 °C anomaly by crash hour of day. The excess is largest for crashes in the hottest part of the day (12-17 h) and weakest in the cool morning (06-11 h).</a:t>
             </a:r>
           </a:p>
         </p:txBody>
@@ -3974,7 +3974,7 @@
           <a:p>
             <a:r>
               <a:rPr sz="1200"/>
-              <a:t>United States projected additional traffic-crash deaths per year under uniform warming of the daily temperature distribution by +1, +2 and +3 C, holding driving activity and baseline rates constant. Bars show the point estimate with 95% Monte Carlo confidence intervals; this is a scenario projection, not an observed quantity.</a:t>
+              <a:t>United States projected additional traffic-crash deaths per year under uniform warming of the daily temperature distribution by +1, +2 and +3 °C, holding driving activity and baseline rates constant. Bars show the point estimate with 95% Monte Carlo confidence intervals; this is a scenario projection, not an observed quantity.</a:t>
             </a:r>
           </a:p>
         </p:txBody>

</xml_diff>

<commit_message>
EHP manuscript: reviewer-suggested improvements (autocorrelation, +9C rationale, limitations, AI note, B/W captions, exploratory labels)
Co-Authored-By: Tatsuki Onishi <bougtoir@gmail.com>
</commit_message>
<xml_diff>
--- a/heat_accidents_mortality/output/manuscript/figures.pptx
+++ b/heat_accidents_mortality/output/manuscript/figures.pptx
@@ -3274,7 +3274,7 @@
           <a:p>
             <a:r>
               <a:rPr sz="1200"/>
-              <a:t>Same-day rate ratio of traffic-crash deaths for a +9 °C anomaly, United States versus Japan. The US shows a precise acute effect; the Japanese estimate is underpowered.</a:t>
+              <a:t>Same-day rate ratio of traffic-crash deaths for a +9 °C anomaly, United States versus Japan. The US shows a precise acute effect; the Japanese estimate is underpowered. This comparison is exploratory and is not adjusted for multiple comparisons.</a:t>
             </a:r>
           </a:p>
         </p:txBody>
@@ -3574,7 +3574,7 @@
           <a:p>
             <a:r>
               <a:rPr sz="1200"/>
-              <a:t>United States same-day rate ratio of crash death for a +9 °C anomaly by road-user type. Open-air users (motorcyclists, pedestrians, cyclists) show much larger heat effects than enclosed, often air-conditioned, vehicle occupants—a gradient that tracks direct heat exposure rather than driving volume.</a:t>
+              <a:t>United States same-day rate ratio of crash death for a +9 °C anomaly by road-user type. Open-air users (motorcyclists, pedestrians, cyclists) show much larger heat effects than enclosed, often air-conditioned, vehicle occupants—a gradient that tracks direct heat exposure rather than driving volume. This subgroup analysis is exploratory and is not adjusted for multiple comparisons.</a:t>
             </a:r>
           </a:p>
         </p:txBody>
@@ -3674,7 +3674,7 @@
           <a:p>
             <a:r>
               <a:rPr sz="1200"/>
-              <a:t>United States same-day rate ratio of crash death for a +9 °C anomaly by crash hour of day. The excess is largest for crashes in the hottest part of the day (12-17 h) and weakest in the cool morning (06-11 h).</a:t>
+              <a:t>United States same-day rate ratio of crash death for a +9 °C anomaly by crash hour of day. The excess is largest for crashes in the hottest part of the day (12-17 h) and weakest in the cool morning (06-11 h). This subgroup analysis is exploratory and is not adjusted for multiple comparisons.</a:t>
             </a:r>
           </a:p>
         </p:txBody>

</xml_diff>